<commit_message>
Read English, think in Korean: the script and the presenter notes now say which is which
He presents in English and reads the notes to himself. Mixing both into one
English paragraph means translating in his head at the moment he has least room
for it, so the split is now explicit everywhere: every sentence he says out loud
stays in English and is quoted; everything else — what to point at, how long to
take, why the slide exists, what a judge will ask — is Korean.

docs/demo/script.md is the sheet to hold on stage: ten time blocks in the order
he will click, the spoken lines set apart from the directions, the four likely
questions with their answers, and the recovery table with something to say while
recovering rather than silence.

All sixteen presenter notes rewritten the same way, and the PPTX and PDF rebuilt
from them.

Co-Authored-By: Claude Opus 5 (1M context) <noreply@anthropic.com>
Claude-Session: https://claude.ai/code/session_0116Vb9wVXrZmn6WvNcpSt34
</commit_message>
<xml_diff>
--- a/docs/demo/deck/dockrisk-deck.pptx
+++ b/docs/demo/deck/dockrisk-deck.pptx
@@ -517,17 +517,22 @@
           <a:lstStyle/>
           <a:p>
             <a:r>
-              <a:t>Open cold, on the bar. "This is one truck's Sunday. The hatched part is the two hours of free time the contract gives the customer. The amber is money. And this red tick — the one that matters — is the moment the driver's next load became impossible. It happens before the amber starts."</a:t>
-            </a:r>
-          </a:p>
-          <a:p>
-            <a:r>
-              <a:t> Then: "Nobody in city dispatch is watching that red tick. That's the whole talk."</a:t>
-            </a:r>
-          </a:p>
-          <a:p>
-            <a:r>
-              <a:t> Keep it to 40 seconds. Do not read the subtitle aloud.</a:t>
+              <a:t>차가운 상태로 시작. 슬라이드 아래 막대를 손으로 짚으면서 연다. 40초 안에 끝낸다. 부제는 소리 내어 읽지 말 것.</a:t>
+            </a:r>
+          </a:p>
+          <a:p>
+            <a:r>
+              <a:t> 말할 것: "This is one truck's Sunday. The hatched part is the two hours of free time the contract gives the customer. The amber is money. And this red tick — the one that matters — is the moment the driver's next load became impossible. It happens before the amber starts."</a:t>
+            </a:r>
+          </a:p>
+          <a:p>
+            <a:r>
+              <a:t> 그 다음: "Nobody in city dispatch is watching that red tick. That's the whole talk."</a:t>
+            </a:r>
+          </a:p>
+          <a:p>
+            <a:r>
+              <a:t> 속도: 40초. 여기서 늘어지면 뒤가 밀린다.</a:t>
             </a:r>
           </a:p>
         </p:txBody>
@@ -597,27 +602,22 @@
           <a:lstStyle/>
           <a:p>
             <a:r>
-              <a:t>• Note the amount on screen is $0.00 — deliberately. Do not skip past it; it is the strongest slide in the deck. "This stop did not earn a charge, and the packet says why. A tool that only shows you the wins is a tool nobody trusts on Monday." </a:t>
-            </a:r>
-          </a:p>
-          <a:p>
-            <a:r>
-              <a:t> </a:t>
-            </a:r>
-          </a:p>
-          <a:p>
-            <a:r>
-              <a:t>• The red review block is the same idea: the system refuses to bill against a city-centroid facility and says so. </a:t>
-            </a:r>
-          </a:p>
-          <a:p>
-            <a:r>
-              <a:t> </a:t>
-            </a:r>
-          </a:p>
-          <a:p>
-            <a:r>
-              <a:t>• If a judge is a carrier operator, this is the slide they will ask about. Let them.</a:t>
+              <a:t>화면의 금액이 $0.00인 것은 의도적이다. 그냥 넘기지 마라 — 덱에서 가장 강한 슬라이드다.</a:t>
+            </a:r>
+          </a:p>
+          <a:p>
+            <a:r>
+              <a:t> 말할 것: "This stop did not earn a charge, and the packet says why. A tool that only shows you the wins is a tool nobody trusts on Monday."</a:t>
+            </a:r>
+          </a:p>
+          <a:p>
+            <a:r>
+              <a:t> 빨간 검토 블록도 같은 생각이다. 도시 중심점으로 추정한 시설에 대해서는 시스템이 청구를 거부하고 이유를 말한다. </a:t>
+            </a:r>
+          </a:p>
+          <a:p>
+            <a:r>
+              <a:t> 심사위원 중에 운송사 운영자가 있으면 이 슬라이드를 물어본다. 물어보게 둬라.</a:t>
             </a:r>
           </a:p>
         </p:txBody>
@@ -687,27 +687,22 @@
           <a:lstStyle/>
           <a:p>
             <a:r>
-              <a:t>• Best Use of AI is a special award, and the honest framing wins it more often than a bigger model does. </a:t>
-            </a:r>
-          </a:p>
-          <a:p>
-            <a:r>
-              <a:t> </a:t>
-            </a:r>
-          </a:p>
-          <a:p>
-            <a:r>
-              <a:t>• Say the rule plainly: "the model reads and writes. It never counts." Judges have sat through six demos where an LLM confidently invented a dollar figure. </a:t>
-            </a:r>
-          </a:p>
-          <a:p>
-            <a:r>
-              <a:t> </a:t>
-            </a:r>
-          </a:p>
-          <a:p>
-            <a:r>
-              <a:t>• Point at the pre-send checklist. The system is arguing against its own draft — that is the detail worth ten seconds.</a:t>
+              <a:t>Best Use of AI는 특별상인데, 정직한 프레이밍이 더 큰 모델보다 자주 이긴다. </a:t>
+            </a:r>
+          </a:p>
+          <a:p>
+            <a:r>
+              <a:t> 규칙을 평범하게 말할 것: "The model reads and writes. It never counts."</a:t>
+            </a:r>
+          </a:p>
+          <a:p>
+            <a:r>
+              <a:t> 심사위원은 오늘 하루 LLM이 자신만만하게 금액을 지어내는 데모를 여섯 번쯤 봤다.</a:t>
+            </a:r>
+          </a:p>
+          <a:p>
+            <a:r>
+              <a:t> 전송 전 확인 목록을 가리켜라. 시스템이 자기 초안을 스스로 반박하고 있다 — 그 디테일이 10초 값어치를 한다.</a:t>
             </a:r>
           </a:p>
         </p:txBody>
@@ -777,27 +772,17 @@
           <a:lstStyle/>
           <a:p>
             <a:r>
-              <a:t>• This is a quiet slide that answers the obvious challenge — "our contracts are all different" — before anyone asks it. </a:t>
-            </a:r>
-          </a:p>
-          <a:p>
-            <a:r>
-              <a:t> </a:t>
-            </a:r>
-          </a:p>
-          <a:p>
-            <a:r>
-              <a:t>• The 225 / 32 split is real and comes from the export. Use it; it proves the point better than the argument does. </a:t>
-            </a:r>
-          </a:p>
-          <a:p>
-            <a:r>
-              <a:t> </a:t>
-            </a:r>
-          </a:p>
-          <a:p>
-            <a:r>
-              <a:t>• Forty seconds. If you are running long, this is the first slide to cut.</a:t>
+              <a:t>조용한 슬라이드인데, "우리 계약은 다 다르다" 는 뻔한 반론을 누가 말하기 전에 답한다.</a:t>
+            </a:r>
+          </a:p>
+          <a:p>
+            <a:r>
+              <a:t> 225 대 32 분할은 추출본에서 나온 실제 숫자 다. 논증보다 이게 더 잘 증명한다.</a:t>
+            </a:r>
+          </a:p>
+          <a:p>
+            <a:r>
+              <a:t> 속도: 40초. 시간이 밀리면 제일 먼저 잘라낼 슬라이드가 이것이다.</a:t>
             </a:r>
           </a:p>
         </p:txBody>
@@ -867,27 +852,32 @@
           <a:lstStyle/>
           <a:p>
             <a:r>
-              <a:t>• Counter-intuitive but true: this slide wins points. Judges have spent the day being told everything works. Naming three things that do not is the fastest credibility you can buy. </a:t>
-            </a:r>
-          </a:p>
-          <a:p>
-            <a:r>
-              <a:t> </a:t>
-            </a:r>
-          </a:p>
-          <a:p>
-            <a:r>
-              <a:t>• The retraction story is the one to tell if you only tell one: "we found a bug in their data, we were wrong, we wrote down that we were wrong." That is Problem Discovery, which the brief lists as a judged area. </a:t>
-            </a:r>
-          </a:p>
-          <a:p>
-            <a:r>
-              <a:t> </a:t>
-            </a:r>
-          </a:p>
-          <a:p>
-            <a:r>
-              <a:t>• Do not sound apologetic. Deliver it as engineering discipline, because it is.</a:t>
+              <a:t>직관에 반하지만 이 슬라이드가 점수를 번다. 심사위원은 하루 종일 "다 됩니다"를 들었다.</a:t>
+            </a:r>
+          </a:p>
+          <a:p>
+            <a:r>
+              <a:t> 안 되는 것 세 가지를 이름 붙여 말하는 게 가장 빠른 신뢰 다.</a:t>
+            </a:r>
+          </a:p>
+          <a:p>
+            <a:r>
+              <a:t> 하나만 말한다면 철회 이야기를 해라.</a:t>
+            </a:r>
+          </a:p>
+          <a:p>
+            <a:r>
+              <a:t> 말할 것: "We found a bug in their data, we were wrong, and we wrote down that we were wrong."</a:t>
+            </a:r>
+          </a:p>
+          <a:p>
+            <a:r>
+              <a:t> 그게 브리프가 채점 항목으로 적어둔 Problem Discovery다.</a:t>
+            </a:r>
+          </a:p>
+          <a:p>
+            <a:r>
+              <a:t> 사과하는 투로 말하지 마라. 공학적 규율로 전달해라. 실제로 그렇기 때문이다.</a:t>
             </a:r>
           </a:p>
         </p:txBody>
@@ -957,27 +947,22 @@
           <a:lstStyle/>
           <a:p>
             <a:r>
-              <a:t>• Use of Provided Data &amp; APIs is 15%, and this slide is the whole of it. Do not skip it to save time — cut slide 12 instead. </a:t>
-            </a:r>
-          </a:p>
-          <a:p>
-            <a:r>
-              <a:t> </a:t>
-            </a:r>
-          </a:p>
-          <a:p>
-            <a:r>
-              <a:t>• Say "satellite toggle" explicitly. The brief states it twice, which means it is on someone's checklist. </a:t>
-            </a:r>
-          </a:p>
-          <a:p>
-            <a:r>
-              <a:t> </a:t>
-            </a:r>
-          </a:p>
-          <a:p>
-            <a:r>
-              <a:t>• The last row is the argument: the bonus question was not an add-on for us, it was the reason the product exists.</a:t>
+              <a:t>Use of Provided Data &amp; APIs가 15%인데 이 슬라이드가 그 전부 다.</a:t>
+            </a:r>
+          </a:p>
+          <a:p>
+            <a:r>
+              <a:t> 시간 아끼려고 건너뛰지 마라 — 대신 12번을 잘라라. </a:t>
+            </a:r>
+          </a:p>
+          <a:p>
+            <a:r>
+              <a:t> "satellite toggle"을 명시적으로 말해라. 브리프가 두 번 적어놨다. 누군가의 체크리스트에 있다는 뜻이다.</a:t>
+            </a:r>
+          </a:p>
+          <a:p>
+            <a:r>
+              <a:t> 마지막 줄이 논증이다 — 보너스 질문은 우리에게 부록이 아니라 제품이 존재하는 이유 였다.</a:t>
             </a:r>
           </a:p>
         </p:txBody>
@@ -1047,27 +1032,17 @@
           <a:lstStyle/>
           <a:p>
             <a:r>
-              <a:t>• Move fast here — thirty seconds. A stack list does not win anything on its own; the two boxes on the right do. </a:t>
-            </a:r>
-          </a:p>
-          <a:p>
-            <a:r>
-              <a:t> </a:t>
-            </a:r>
-          </a:p>
-          <a:p>
-            <a:r>
-              <a:t>• "Survives an API restart" and "deterministic from a seed" are the phrases that matter to a technical judge. Say both. </a:t>
-            </a:r>
-          </a:p>
-          <a:p>
-            <a:r>
-              <a:t> </a:t>
-            </a:r>
-          </a:p>
-          <a:p>
-            <a:r>
-              <a:t>• If someone asks why a separate simulator: the brief requires it, and it is also the only honest way to demo a historical export where every leg is already finished.</a:t>
+              <a:t>빠르게 지나간다 — 30초. 기술 스택 나열은 그 자체로는 아무것도 못 번다. 오른쪽 두 상자가 번다.</a:t>
+            </a:r>
+          </a:p>
+          <a:p>
+            <a:r>
+              <a:t> 이 두 문장은 꼭 말할 것: "It survives an API restart." / "It is deterministic from a seed."</a:t>
+            </a:r>
+          </a:p>
+          <a:p>
+            <a:r>
+              <a:t> "왜 시뮬레이터를 따로 뒀나?" 질문이 오면: "The brief requires it — and it is the only honest way to demo a historical export where every leg is already finished."</a:t>
             </a:r>
           </a:p>
         </p:txBody>
@@ -1137,27 +1112,32 @@
           <a:lstStyle/>
           <a:p>
             <a:r>
-              <a:t>• End on the sentence, not on "any questions?". Say it, tap the red tick, stop talking. </a:t>
-            </a:r>
-          </a:p>
-          <a:p>
-            <a:r>
-              <a:t> </a:t>
-            </a:r>
-          </a:p>
-          <a:p>
-            <a:r>
-              <a:t>• Leave this slide up through Q&amp;A — the URLs stay on screen while judges are writing. </a:t>
-            </a:r>
-          </a:p>
-          <a:p>
-            <a:r>
-              <a:t> </a:t>
-            </a:r>
-          </a:p>
-          <a:p>
-            <a:r>
-              <a:t>• Likely questions: why not just use the TMS? (it computes after the fact, from timestamps nobody enters) · how do you know the dwell prediction generalises? (we do not, past n=9 per city — that is why n is on screen) · what would you build next? (verified dock geometry, then the appointment renegotiation the desk currently does by phone).</a:t>
+              <a:t>문장으로 끝낸다. "질문 있나요?"로 끝내지 마라. 말하고, 빨간 눈금을 짚고, 입을 다문다.</a:t>
+            </a:r>
+          </a:p>
+          <a:p>
+            <a:r>
+              <a:t> 이 슬라이드를 Q&amp;A 내내 띄워둔다 — 심사위원이 적는 동안 URL이 화면에 남아 있게.</a:t>
+            </a:r>
+          </a:p>
+          <a:p>
+            <a:r>
+              <a:t> 예상 질문과 답: </a:t>
+            </a:r>
+          </a:p>
+          <a:p>
+            <a:r>
+              <a:t> "Why not just use the TMS?" — "It computes after the fact, from timestamps nobody enters."</a:t>
+            </a:r>
+          </a:p>
+          <a:p>
+            <a:r>
+              <a:t> "How do you know the dwell prediction generalises?" — "We do not, past n=9 per city. That is why n is on the screen."</a:t>
+            </a:r>
+          </a:p>
+          <a:p>
+            <a:r>
+              <a:t> "What would you build next?" — "Verified dock geometry, then the appointment renegotiation the desk currently does by phone."</a:t>
             </a:r>
           </a:p>
         </p:txBody>
@@ -1227,27 +1207,22 @@
           <a:lstStyle/>
           <a:p>
             <a:r>
-              <a:t>• Land the asymmetry: the visible loss is an accounting problem, the invisible one is an operations problem. Only the second one is still open. </a:t>
-            </a:r>
-          </a:p>
-          <a:p>
-            <a:r>
-              <a:t> </a:t>
-            </a:r>
-          </a:p>
-          <a:p>
-            <a:r>
-              <a:t>• The last line is the organizers' own bonus-focus question, quoted from the brief. Say that out loud — "this is your question, not ours." It buys credibility for the next four minutes. </a:t>
-            </a:r>
-          </a:p>
-          <a:p>
-            <a:r>
-              <a:t> </a:t>
-            </a:r>
-          </a:p>
-          <a:p>
-            <a:r>
-              <a:t>• ~60 seconds. Do not linger; the numbers slide does the convincing.</a:t>
+              <a:t>비대칭을 꽂는 게 목적이다. 보이는 손실은 회계 문제, 안 보이는 손실은 운영 문제다. 아직 안 풀린 건 두 번째뿐.</a:t>
+            </a:r>
+          </a:p>
+          <a:p>
+            <a:r>
+              <a:t> 마지막 줄은 주최측 브리프의 보너스 질문을 그대로 인용한 것 이다. 그걸 소리 내어 말하면 신뢰가 생긴다.</a:t>
+            </a:r>
+          </a:p>
+          <a:p>
+            <a:r>
+              <a:t> 말할 것: "This is your question, not ours."</a:t>
+            </a:r>
+          </a:p>
+          <a:p>
+            <a:r>
+              <a:t> 속도: 60초. 오래 끌지 말 것 — 설득은 다음 숫자 슬라이드가 한다.</a:t>
             </a:r>
           </a:p>
         </p:txBody>
@@ -1317,37 +1292,22 @@
           <a:lstStyle/>
           <a:p>
             <a:r>
-              <a:t>• This is the Industry Impact slide — 25% of the score, the heaviest single criterion. Slow down here. </a:t>
-            </a:r>
-          </a:p>
-          <a:p>
-            <a:r>
-              <a:t> </a:t>
-            </a:r>
-          </a:p>
-          <a:p>
-            <a:r>
-              <a:t>• Point at $31k and say: "that is one month, one mid-size carrier, from your file." </a:t>
-            </a:r>
-          </a:p>
-          <a:p>
-            <a:r>
-              <a:t> </a:t>
-            </a:r>
-          </a:p>
-          <a:p>
-            <a:r>
-              <a:t>• The last paragraph is deliberate. A fleet GM in the room will grade you on saying exposure instead of unbilled . Say the distinction out loud — it signals you read the data instead of the pitch deck. </a:t>
-            </a:r>
-          </a:p>
-          <a:p>
-            <a:r>
-              <a:t> </a:t>
-            </a:r>
-          </a:p>
-          <a:p>
-            <a:r>
-              <a:t>• If asked "is 79% precision good?" — answer: a false positive costs a dispatcher one glance; a false negative costs the charge and the load.</a:t>
+              <a:t>Industry Impact 슬라이드다. 25%로 배점이 가장 크다. 여기서 속도를 늦춘다. $31k를 손으로 가리킨다.</a:t>
+            </a:r>
+          </a:p>
+          <a:p>
+            <a:r>
+              <a:t> 말할 것: "That is one month, one mid-size carrier, from your file."</a:t>
+            </a:r>
+          </a:p>
+          <a:p>
+            <a:r>
+              <a:t> 마지막 문단이 핵심이다. 현장 운송사 임원은 unbilled 대신 exposure 라고 말하는지로 채점한다. 그 구분을 소리 내어 말하면 "데이터를 읽었다"는 신호가 된다.</a:t>
+            </a:r>
+          </a:p>
+          <a:p>
+            <a:r>
+              <a:t> "79% 정확도면 좋은 건가?" 질문이 오면: "A false positive costs a dispatcher one glance. A false negative costs the charge and the load."</a:t>
             </a:r>
           </a:p>
         </p:txBody>
@@ -1417,37 +1377,27 @@
           <a:lstStyle/>
           <a:p>
             <a:r>
-              <a:t>• The point of this slide is why nobody has solved it already : the average stop looks fine. You cannot staff for a problem whose median is "no problem." </a:t>
-            </a:r>
-          </a:p>
-          <a:p>
-            <a:r>
-              <a:t> </a:t>
-            </a:r>
-          </a:p>
-          <a:p>
-            <a:r>
-              <a:t>• "Nearly three times" — say the two numbers, $41.9k and $15.0k, don't just say the ratio. </a:t>
-            </a:r>
-          </a:p>
-          <a:p>
-            <a:r>
-              <a:t> </a:t>
-            </a:r>
-          </a:p>
-          <a:p>
-            <a:r>
-              <a:t>• The chart on the right is a real product screen, not a slide graphic. Mention that once; it earns Technical Execution points quietly. </a:t>
-            </a:r>
-          </a:p>
-          <a:p>
-            <a:r>
-              <a:t> </a:t>
-            </a:r>
-          </a:p>
-          <a:p>
-            <a:r>
-              <a:t>• ~50 seconds.</a:t>
+              <a:t>이 슬라이드의 목적은 왜 아무도 이걸 이미 풀지 않았나 다. 평균만 보면 멀쩡해 보이기 때문이다.</a:t>
+            </a:r>
+          </a:p>
+          <a:p>
+            <a:r>
+              <a:t> 말할 것: "You cannot staff for a problem whose median is 'no problem.'"</a:t>
+            </a:r>
+          </a:p>
+          <a:p>
+            <a:r>
+              <a:t> "거의 세 배"라고 비율만 말하지 말고 두 숫자를 다 말한다 — $41.9k와 $15.0k.</a:t>
+            </a:r>
+          </a:p>
+          <a:p>
+            <a:r>
+              <a:t> 오른쪽 차트는 슬라이드 그래픽이 아니라 실제 제품 화면 이다. 한 번 언급하면 기술 점수가 조용히 올라간다.</a:t>
+            </a:r>
+          </a:p>
+          <a:p>
+            <a:r>
+              <a:t> 속도: 50초.</a:t>
             </a:r>
           </a:p>
         </p:txBody>
@@ -1517,37 +1467,22 @@
           <a:lstStyle/>
           <a:p>
             <a:r>
-              <a:t>• This is the slide the whole talk is built on. If they remember one thing, it is that the red tick sits to the left of the amber. </a:t>
-            </a:r>
-          </a:p>
-          <a:p>
-            <a:r>
-              <a:t> </a:t>
-            </a:r>
-          </a:p>
-          <a:p>
-            <a:r>
-              <a:t>• Let the bar finish drawing before you speak. The amber block is the last thing to appear — that timing is the argument. </a:t>
-            </a:r>
-          </a:p>
-          <a:p>
-            <a:r>
-              <a:t> </a:t>
-            </a:r>
-          </a:p>
-          <a:p>
-            <a:r>
-              <a:t>• Trace it with your hand: "on duty… driving… he arrives… free time… and here" — tap the red tick — "the next load is already gone. Thirty-seven minutes before anybody's detention timer even starts." </a:t>
-            </a:r>
-          </a:p>
-          <a:p>
-            <a:r>
-              <a:t> </a:t>
-            </a:r>
-          </a:p>
-          <a:p>
-            <a:r>
-              <a:t>• Innovation is 20%. This is where you earn it. Do not rush.</a:t>
+              <a:t>발표 전체가 이 슬라이드 위에 서 있다. 하나만 기억시킨다면 빨간 눈금이 황색보다 왼쪽에 있다 는 것.</a:t>
+            </a:r>
+          </a:p>
+          <a:p>
+            <a:r>
+              <a:t> 막대가 다 그려질 때까지 기다렸다 말한다. 황색이 마지막에 나타나는데, 그 타이밍 자체가 논증이다.</a:t>
+            </a:r>
+          </a:p>
+          <a:p>
+            <a:r>
+              <a:t> 손으로 훑으면서 말할 것: "On duty… driving… he arrives… free time… and here" — (빨간 눈금을 짚으며) — "the next load is already gone. Thirty-seven minutes before anybody's detention timer even starts."</a:t>
+            </a:r>
+          </a:p>
+          <a:p>
+            <a:r>
+              <a:t> Innovation이 20%다. 여기서 벌어들인다. 서두르지 마라.</a:t>
             </a:r>
           </a:p>
         </p:txBody>
@@ -1617,37 +1552,22 @@
           <a:lstStyle/>
           <a:p>
             <a:r>
-              <a:t>• Do not narrate the whole screen. Name three things and move: the map, the ranked board, the road strip underneath. </a:t>
-            </a:r>
-          </a:p>
-          <a:p>
-            <a:r>
-              <a:t> </a:t>
-            </a:r>
-          </a:p>
-          <a:p>
-            <a:r>
-              <a:t>• "Eight trucks. Only one is a problem. It is at the top because it is the most urgent, not because it arrived first." </a:t>
-            </a:r>
-          </a:p>
-          <a:p>
-            <a:r>
-              <a:t> </a:t>
-            </a:r>
-          </a:p>
-          <a:p>
-            <a:r>
-              <a:t>• If the projector is washing out the map, skip straight to the next slide — the numbers there are the point, not the pixels. </a:t>
-            </a:r>
-          </a:p>
-          <a:p>
-            <a:r>
-              <a:t> </a:t>
-            </a:r>
-          </a:p>
-          <a:p>
-            <a:r>
-              <a:t>• This is the natural place to switch to the live app. Decide beforehand: slide 6 or slide 9. Do not decide on stage.</a:t>
+              <a:t>화면 전체를 설명하지 마라. 세 가지만 짚고 넘어간다 — 지도, 순위 보드, 아래 도로 줄.</a:t>
+            </a:r>
+          </a:p>
+          <a:p>
+            <a:r>
+              <a:t> 말할 것: "Eight trucks. Only one is a problem. It is at the top because it is the most urgent, not because it arrived first."</a:t>
+            </a:r>
+          </a:p>
+          <a:p>
+            <a:r>
+              <a:t> 프로젝터에서 지도가 날아가 보이면 바로 다음 슬라이드로 넘어가라. 여기서 중요한 건 숫자지 픽셀이 아니다.</a:t>
+            </a:r>
+          </a:p>
+          <a:p>
+            <a:r>
+              <a:t> 결정: 라이브 앱으로 넘어가는 지점은 6번이나 9번이다. 미리 정해라. 무대에서 정하지 마라.</a:t>
             </a:r>
           </a:p>
         </p:txBody>
@@ -1717,37 +1637,32 @@
           <a:lstStyle/>
           <a:p>
             <a:r>
-              <a:t>• Read the three clocks left to right, then stop. Let the red block do its own work. </a:t>
-            </a:r>
-          </a:p>
-          <a:p>
-            <a:r>
-              <a:t> </a:t>
-            </a:r>
-          </a:p>
-          <a:p>
-            <a:r>
-              <a:t>• The negative margins are the punchline: "minus forty-nine minutes. Even if they release him this second, he cannot make the pickup legally." </a:t>
-            </a:r>
-          </a:p>
-          <a:p>
-            <a:r>
-              <a:t> </a:t>
-            </a:r>
-          </a:p>
-          <a:p>
-            <a:r>
-              <a:t>• "n=9" is deliberate and worth pointing at — we show the sample size behind the prediction rather than hiding a thin one. If a judge asks whether nine is enough: no, and that is why the number is on the screen. </a:t>
-            </a:r>
-          </a:p>
-          <a:p>
-            <a:r>
-              <a:t> </a:t>
-            </a:r>
-          </a:p>
-          <a:p>
-            <a:r>
-              <a:t>• Technical Execution is 20%. This slide plus the packet slide carry it.</a:t>
+              <a:t>세 시계를 왼쪽에서 오른쪽으로 읽고 멈춘다. 빨간 블록이 알아서 일하게 둔다.</a:t>
+            </a:r>
+          </a:p>
+          <a:p>
+            <a:r>
+              <a:t> 음수 여유가 펀치라인이다.</a:t>
+            </a:r>
+          </a:p>
+          <a:p>
+            <a:r>
+              <a:t> 말할 것: "Minus forty-nine minutes. Even if they release him this second, he cannot make the pickup legally."</a:t>
+            </a:r>
+          </a:p>
+          <a:p>
+            <a:r>
+              <a:t> n=9는 일부러 띄운 것 이고 가리킬 값어치가 있다. 표본이 얇으면 얇다고 보여준다.</a:t>
+            </a:r>
+          </a:p>
+          <a:p>
+            <a:r>
+              <a:t> "9개면 충분한가?" 질문이 오면: "No — and that is exactly why the number is on the screen."</a:t>
+            </a:r>
+          </a:p>
+          <a:p>
+            <a:r>
+              <a:t> Technical Execution이 20%다. 이 슬라이드와 증거 패킷 슬라이드가 그걸 짊어진다.</a:t>
             </a:r>
           </a:p>
         </p:txBody>
@@ -1817,27 +1732,22 @@
           <a:lstStyle/>
           <a:p>
             <a:r>
-              <a:t>• The driver app exists because the check-in tap is evidence , not UX garnish. Say that: "this tap is what makes the charge defensible — it is the difference between a claim and an argument." </a:t>
-            </a:r>
-          </a:p>
-          <a:p>
-            <a:r>
-              <a:t> </a:t>
-            </a:r>
-          </a:p>
-          <a:p>
-            <a:r>
-              <a:t>• Best Mobile App is one of the five special awards. Thirty seconds here is cheap. </a:t>
-            </a:r>
-          </a:p>
-          <a:p>
-            <a:r>
-              <a:t> </a:t>
-            </a:r>
-          </a:p>
-          <a:p>
-            <a:r>
-              <a:t>• Do not oversell: read the grey line at the bottom out loud. Claiming ELD certification in front of a fleet operator would be a bad thirty seconds.</a:t>
+              <a:t>기사 앱이 있는 이유는 체크인 탭이 증거이기 때문 이지 UI 장식이 아니다.</a:t>
+            </a:r>
+          </a:p>
+          <a:p>
+            <a:r>
+              <a:t> 말할 것: "This tap is what makes the charge defensible — it is the difference between a claim and an argument."</a:t>
+            </a:r>
+          </a:p>
+          <a:p>
+            <a:r>
+              <a:t> Best Mobile App이 특별상 다섯 개 중 하나다. 여기 30초는 싸게 먹힌다.</a:t>
+            </a:r>
+          </a:p>
+          <a:p>
+            <a:r>
+              <a:t> 과장하지 마라. 맨 아래 회색 줄을 소리 내어 읽어라. 운송사 사람 앞에서 ELD 인증을 주장하면 30초 만에 신뢰를 잃는다.</a:t>
             </a:r>
           </a:p>
         </p:txBody>
@@ -1907,37 +1817,27 @@
           <a:lstStyle/>
           <a:p>
             <a:r>
-              <a:t>• The single biggest risk in the whole presentation. "Failed demo" is the explicit 1-out-of-5 anchor for Presentation &amp; Demo Quality. </a:t>
-            </a:r>
-          </a:p>
-          <a:p>
-            <a:r>
-              <a:t> </a:t>
-            </a:r>
-          </a:p>
-          <a:p>
-            <a:r>
-              <a:t>• Rule for the day: if the live app is not showing what you want within fifteen seconds , hit play on this video and carry on narrating. Never debug on stage. </a:t>
-            </a:r>
-          </a:p>
-          <a:p>
-            <a:r>
-              <a:t> </a:t>
-            </a:r>
-          </a:p>
-          <a:p>
-            <a:r>
-              <a:t>• Warm the tile cache and the simulator before doors close. Have the scenario already at ~11:00. </a:t>
-            </a:r>
-          </a:p>
-          <a:p>
-            <a:r>
-              <a:t> </a:t>
-            </a:r>
-          </a:p>
-          <a:p>
-            <a:r>
-              <a:t>• Budget six to seven minutes here. It is the longest single block; everything before it was setup.</a:t>
+              <a:t>발표 전체에서 가장 큰 위험 구간이다. "실패한 데모"가 Presentation 항목의 1/5점 앵커로 명시돼 있다.</a:t>
+            </a:r>
+          </a:p>
+          <a:p>
+            <a:r>
+              <a:t> 오늘의 규칙: 라이브 앱이 15초 안에 원하는 걸 안 보여주면, 영상을 틀고 설명을 이어간다. </a:t>
+            </a:r>
+          </a:p>
+          <a:p>
+            <a:r>
+              <a:t> 무대에서 디버깅하지 마라. 절대로.</a:t>
+            </a:r>
+          </a:p>
+          <a:p>
+            <a:r>
+              <a:t> 준비: 문 닫히기 전에 타일 캐시와 시뮬레이터를 데워둔다. 시나리오를 미리 11:00 근처에 맞춰둔다.</a:t>
+            </a:r>
+          </a:p>
+          <a:p>
+            <a:r>
+              <a:t> 시간: 6~7분. 가장 긴 구간이고, 앞의 모든 것이 이걸 위한 준비였다.</a:t>
             </a:r>
           </a:p>
         </p:txBody>

</xml_diff>